<commit_message>
DD-vs-error dot plot + CPU-force option for reduced-antenna runs
fig_dd_error_dots.py: regression analog of the classification DD-accuracy dot
plot (color=DD, size=error). Shows DD does NOT predict regression error
(corr empty -0.18, F4 -0.47, F5 +0.15) -- unlike classification where accuracy
tracked signal. Regression error is geometry-driven (F5 edge error ~2.5x
interior, plus the insert barrier). Added CNN_LOSO_FORCE_CPU to RegLOSO so the
reduced-antenna runs use CPU (no GPU contention with the F4 job).

Co-Authored-By: Claude Opus 4.8 <noreply@anthropic.com>
</commit_message>
<xml_diff>
--- a/presentation/CNN_vs_MLP_Comparison.pptx
+++ b/presentation/CNN_vs_MLP_Comparison.pptx
@@ -3527,7 +3527,7 @@
     <p:bg>
       <p:bgPr>
         <a:solidFill>
-          <a:srgbClr val="BE0000"/>
+          <a:srgbClr val="FDF8F6"/>
         </a:solidFill>
       </p:bgPr>
     </p:bg>
@@ -3547,14 +3547,54 @@
       </p:grpSpPr>
       <p:sp>
         <p:nvSpPr>
-          <p:cNvPr id="2" name="Text 0"/>
+          <p:cNvPr id="2" name="Shape 0"/>
           <p:cNvSpPr/>
           <p:nvPr/>
         </p:nvSpPr>
         <p:spPr>
           <a:xfrm>
-            <a:off x="640080" y="1371600"/>
-            <a:ext cx="7863840" cy="365760"/>
+            <a:off x="0" y="0"/>
+            <a:ext cx="9144000" cy="182880"/>
+          </a:xfrm>
+          <a:prstGeom prst="rect">
+            <a:avLst/>
+          </a:prstGeom>
+          <a:solidFill>
+            <a:srgbClr val="BE0000"/>
+          </a:solidFill>
+          <a:ln/>
+        </p:spPr>
+      </p:sp>
+      <p:sp>
+        <p:nvSpPr>
+          <p:cNvPr id="3" name="Shape 1"/>
+          <p:cNvSpPr/>
+          <p:nvPr/>
+        </p:nvSpPr>
+        <p:spPr>
+          <a:xfrm>
+            <a:off x="621792" y="1389888"/>
+            <a:ext cx="64008" cy="1481328"/>
+          </a:xfrm>
+          <a:prstGeom prst="rect">
+            <a:avLst/>
+          </a:prstGeom>
+          <a:solidFill>
+            <a:srgbClr val="BE0000"/>
+          </a:solidFill>
+          <a:ln/>
+        </p:spPr>
+      </p:sp>
+      <p:sp>
+        <p:nvSpPr>
+          <p:cNvPr id="4" name="Text 2"/>
+          <p:cNvSpPr/>
+          <p:nvPr/>
+        </p:nvSpPr>
+        <p:spPr>
+          <a:xfrm>
+            <a:off x="841248" y="1417320"/>
+            <a:ext cx="7680960" cy="320040"/>
           </a:xfrm>
           <a:prstGeom prst="rect">
             <a:avLst/>
@@ -3570,9 +3610,9 @@
               <a:buNone/>
             </a:pPr>
             <a:r>
-              <a:rPr lang="en-US" sz="1500" b="1" spc="300" kern="0" dirty="0">
+              <a:rPr lang="en-US" sz="1300" b="1" spc="300" kern="0" dirty="0">
                 <a:solidFill>
-                  <a:srgbClr val="F5B8B8"/>
+                  <a:srgbClr val="BE0000"/>
                 </a:solidFill>
                 <a:latin typeface="Calibri" pitchFamily="34" charset="0"/>
                 <a:ea typeface="Calibri" pitchFamily="34" charset="-122"/>
@@ -3580,20 +3620,20 @@
               </a:rPr>
               <a:t>TUMOR LOCALIZATION IN BREAST PHANTOMS</a:t>
             </a:r>
-            <a:endParaRPr lang="en-US" sz="1500" dirty="0"/>
+            <a:endParaRPr lang="en-US" sz="1300" dirty="0"/>
           </a:p>
         </p:txBody>
       </p:sp>
       <p:sp>
         <p:nvSpPr>
-          <p:cNvPr id="3" name="Text 1"/>
+          <p:cNvPr id="5" name="Text 3"/>
           <p:cNvSpPr/>
           <p:nvPr/>
         </p:nvSpPr>
         <p:spPr>
           <a:xfrm>
-            <a:off x="640080" y="1783080"/>
-            <a:ext cx="7863840" cy="1005840"/>
+            <a:off x="841248" y="1783080"/>
+            <a:ext cx="7680960" cy="914400"/>
           </a:xfrm>
           <a:prstGeom prst="rect">
             <a:avLst/>
@@ -3609,30 +3649,30 @@
               <a:buNone/>
             </a:pPr>
             <a:r>
-              <a:rPr lang="en-US" sz="6000" b="1" dirty="0">
+              <a:rPr lang="en-US" sz="5400" b="1" dirty="0">
                 <a:solidFill>
-                  <a:srgbClr val="FFFFFF"/>
+                  <a:srgbClr val="2A1618"/>
                 </a:solidFill>
-                <a:latin typeface="Calibri" pitchFamily="34" charset="0"/>
-                <a:ea typeface="Calibri" pitchFamily="34" charset="-122"/>
-                <a:cs typeface="Calibri" pitchFamily="34" charset="-120"/>
+                <a:latin typeface="Cambria" pitchFamily="34" charset="0"/>
+                <a:ea typeface="Cambria" pitchFamily="34" charset="-122"/>
+                <a:cs typeface="Cambria" pitchFamily="34" charset="-120"/>
               </a:rPr>
               <a:t>CNN vs MLP</a:t>
             </a:r>
-            <a:endParaRPr lang="en-US" sz="6000" dirty="0"/>
+            <a:endParaRPr lang="en-US" sz="5400" dirty="0"/>
           </a:p>
         </p:txBody>
       </p:sp>
       <p:sp>
         <p:nvSpPr>
-          <p:cNvPr id="4" name="Text 2"/>
+          <p:cNvPr id="6" name="Text 4"/>
           <p:cNvSpPr/>
           <p:nvPr/>
         </p:nvSpPr>
         <p:spPr>
           <a:xfrm>
-            <a:off x="640080" y="2880360"/>
-            <a:ext cx="7863840" cy="731520"/>
+            <a:off x="841248" y="2834640"/>
+            <a:ext cx="7498080" cy="685800"/>
           </a:xfrm>
           <a:prstGeom prst="rect">
             <a:avLst/>
@@ -3648,9 +3688,9 @@
               <a:buNone/>
             </a:pPr>
             <a:r>
-              <a:rPr lang="en-US" sz="1600" dirty="0">
+              <a:rPr lang="en-US" sz="1500" dirty="0">
                 <a:solidFill>
-                  <a:srgbClr val="FFD9D9"/>
+                  <a:srgbClr val="836A68"/>
                 </a:solidFill>
                 <a:latin typeface="Calibri" pitchFamily="34" charset="0"/>
                 <a:ea typeface="Calibri" pitchFamily="34" charset="-122"/>
@@ -3658,16 +3698,16 @@
               </a:rPr>
               <a:t>A matched, head-to-head comparison of two machine-learning approaches</a:t>
             </a:r>
-            <a:endParaRPr lang="en-US" sz="1600" dirty="0"/>
+            <a:endParaRPr lang="en-US" sz="1500" dirty="0"/>
           </a:p>
           <a:p>
             <a:pPr indent="0" marL="0">
               <a:buNone/>
             </a:pPr>
             <a:r>
-              <a:rPr lang="en-US" sz="1600" dirty="0">
+              <a:rPr lang="en-US" sz="1500" dirty="0">
                 <a:solidFill>
-                  <a:srgbClr val="FFD9D9"/>
+                  <a:srgbClr val="836A68"/>
                 </a:solidFill>
                 <a:latin typeface="Calibri" pitchFamily="34" charset="0"/>
                 <a:ea typeface="Calibri" pitchFamily="34" charset="-122"/>
@@ -3675,20 +3715,20 @@
               </a:rPr>
               <a:t>for microwave tumor localization</a:t>
             </a:r>
-            <a:endParaRPr lang="en-US" sz="1600" dirty="0"/>
+            <a:endParaRPr lang="en-US" sz="1500" dirty="0"/>
           </a:p>
         </p:txBody>
       </p:sp>
       <p:sp>
         <p:nvSpPr>
-          <p:cNvPr id="5" name="Text 3"/>
+          <p:cNvPr id="7" name="Text 5"/>
           <p:cNvSpPr/>
           <p:nvPr/>
         </p:nvSpPr>
         <p:spPr>
           <a:xfrm>
-            <a:off x="640080" y="4434840"/>
-            <a:ext cx="7863840" cy="320040"/>
+            <a:off x="841248" y="4343400"/>
+            <a:ext cx="7680960" cy="320040"/>
           </a:xfrm>
           <a:prstGeom prst="rect">
             <a:avLst/>
@@ -3704,9 +3744,9 @@
               <a:buNone/>
             </a:pPr>
             <a:r>
-              <a:rPr lang="en-US" sz="1300" dirty="0">
+              <a:rPr lang="en-US" sz="1250" dirty="0">
                 <a:solidFill>
-                  <a:srgbClr val="F5B8B8"/>
+                  <a:srgbClr val="836A68"/>
                 </a:solidFill>
                 <a:latin typeface="Calibri" pitchFamily="34" charset="0"/>
                 <a:ea typeface="Calibri" pitchFamily="34" charset="-122"/>
@@ -3714,20 +3754,20 @@
               </a:rPr>
               <a:t>Peter Martin  ·  University of Utah  ·  Electrical &amp; Computer Engineering</a:t>
             </a:r>
-            <a:endParaRPr lang="en-US" sz="1300" dirty="0"/>
+            <a:endParaRPr lang="en-US" sz="1250" dirty="0"/>
           </a:p>
         </p:txBody>
       </p:sp>
       <p:sp>
         <p:nvSpPr>
-          <p:cNvPr id="6" name="Text 4"/>
+          <p:cNvPr id="8" name="Text 6"/>
           <p:cNvSpPr/>
           <p:nvPr/>
         </p:nvSpPr>
         <p:spPr>
           <a:xfrm>
-            <a:off x="640080" y="4754880"/>
-            <a:ext cx="7863840" cy="274320"/>
+            <a:off x="841248" y="4681728"/>
+            <a:ext cx="7680960" cy="274320"/>
           </a:xfrm>
           <a:prstGeom prst="rect">
             <a:avLst/>
@@ -3745,7 +3785,7 @@
             <a:r>
               <a:rPr lang="en-US" sz="1100" i="1" dirty="0">
                 <a:solidFill>
-                  <a:srgbClr val="F5B8B8"/>
+                  <a:srgbClr val="836A68"/>
                 </a:solidFill>
                 <a:latin typeface="Calibri" pitchFamily="34" charset="0"/>
                 <a:ea typeface="Calibri" pitchFamily="34" charset="-122"/>
@@ -3771,7 +3811,7 @@
     <p:bg>
       <p:bgPr>
         <a:solidFill>
-          <a:srgbClr val="BE0000"/>
+          <a:srgbClr val="FDF8F6"/>
         </a:solidFill>
       </p:bgPr>
     </p:bg>
@@ -3791,14 +3831,54 @@
       </p:grpSpPr>
       <p:sp>
         <p:nvSpPr>
-          <p:cNvPr id="2" name="Text 0"/>
+          <p:cNvPr id="2" name="Shape 0"/>
           <p:cNvSpPr/>
           <p:nvPr/>
         </p:nvSpPr>
         <p:spPr>
           <a:xfrm>
-            <a:off x="640080" y="1600200"/>
-            <a:ext cx="7863840" cy="365760"/>
+            <a:off x="0" y="0"/>
+            <a:ext cx="9144000" cy="182880"/>
+          </a:xfrm>
+          <a:prstGeom prst="rect">
+            <a:avLst/>
+          </a:prstGeom>
+          <a:solidFill>
+            <a:srgbClr val="BE0000"/>
+          </a:solidFill>
+          <a:ln/>
+        </p:spPr>
+      </p:sp>
+      <p:sp>
+        <p:nvSpPr>
+          <p:cNvPr id="3" name="Shape 1"/>
+          <p:cNvSpPr/>
+          <p:nvPr/>
+        </p:nvSpPr>
+        <p:spPr>
+          <a:xfrm>
+            <a:off x="621792" y="1847088"/>
+            <a:ext cx="64008" cy="1051560"/>
+          </a:xfrm>
+          <a:prstGeom prst="rect">
+            <a:avLst/>
+          </a:prstGeom>
+          <a:solidFill>
+            <a:srgbClr val="BE0000"/>
+          </a:solidFill>
+          <a:ln/>
+        </p:spPr>
+      </p:sp>
+      <p:sp>
+        <p:nvSpPr>
+          <p:cNvPr id="4" name="Text 2"/>
+          <p:cNvSpPr/>
+          <p:nvPr/>
+        </p:nvSpPr>
+        <p:spPr>
+          <a:xfrm>
+            <a:off x="841248" y="1874520"/>
+            <a:ext cx="7680960" cy="320040"/>
           </a:xfrm>
           <a:prstGeom prst="rect">
             <a:avLst/>
@@ -3814,9 +3894,9 @@
               <a:buNone/>
             </a:pPr>
             <a:r>
-              <a:rPr lang="en-US" sz="1400" b="1" spc="300" kern="0" dirty="0">
+              <a:rPr lang="en-US" sz="1250" b="1" spc="300" kern="0" dirty="0">
                 <a:solidFill>
-                  <a:srgbClr val="F5B8B8"/>
+                  <a:srgbClr val="BE0000"/>
                 </a:solidFill>
                 <a:latin typeface="Calibri" pitchFamily="34" charset="0"/>
                 <a:ea typeface="Calibri" pitchFamily="34" charset="-122"/>
@@ -3824,20 +3904,20 @@
               </a:rPr>
               <a:t>PART 2</a:t>
             </a:r>
-            <a:endParaRPr lang="en-US" sz="1400" dirty="0"/>
+            <a:endParaRPr lang="en-US" sz="1250" dirty="0"/>
           </a:p>
         </p:txBody>
       </p:sp>
       <p:sp>
         <p:nvSpPr>
-          <p:cNvPr id="3" name="Text 1"/>
+          <p:cNvPr id="5" name="Text 3"/>
           <p:cNvSpPr/>
           <p:nvPr/>
         </p:nvSpPr>
         <p:spPr>
           <a:xfrm>
-            <a:off x="640080" y="1965960"/>
-            <a:ext cx="7863840" cy="914400"/>
+            <a:off x="841248" y="2212848"/>
+            <a:ext cx="7680960" cy="685800"/>
           </a:xfrm>
           <a:prstGeom prst="rect">
             <a:avLst/>
@@ -3853,30 +3933,30 @@
               <a:buNone/>
             </a:pPr>
             <a:r>
-              <a:rPr lang="en-US" sz="4000" b="1" dirty="0">
+              <a:rPr lang="en-US" sz="3300" b="1" dirty="0">
                 <a:solidFill>
-                  <a:srgbClr val="FFFFFF"/>
+                  <a:srgbClr val="2A1618"/>
                 </a:solidFill>
-                <a:latin typeface="Calibri" pitchFamily="34" charset="0"/>
-                <a:ea typeface="Calibri" pitchFamily="34" charset="-122"/>
-                <a:cs typeface="Calibri" pitchFamily="34" charset="-120"/>
+                <a:latin typeface="Cambria" pitchFamily="34" charset="0"/>
+                <a:ea typeface="Cambria" pitchFamily="34" charset="-122"/>
+                <a:cs typeface="Cambria" pitchFamily="34" charset="-120"/>
               </a:rPr>
               <a:t>The data pipeline</a:t>
             </a:r>
-            <a:endParaRPr lang="en-US" sz="4000" dirty="0"/>
+            <a:endParaRPr lang="en-US" sz="3300" dirty="0"/>
           </a:p>
         </p:txBody>
       </p:sp>
       <p:sp>
         <p:nvSpPr>
-          <p:cNvPr id="4" name="Text 2"/>
+          <p:cNvPr id="6" name="Text 4"/>
           <p:cNvSpPr/>
           <p:nvPr/>
         </p:nvSpPr>
         <p:spPr>
           <a:xfrm>
-            <a:off x="640080" y="2971800"/>
-            <a:ext cx="7863840" cy="822960"/>
+            <a:off x="841248" y="2999232"/>
+            <a:ext cx="7498080" cy="731520"/>
           </a:xfrm>
           <a:prstGeom prst="rect">
             <a:avLst/>
@@ -3892,9 +3972,9 @@
               <a:buNone/>
             </a:pPr>
             <a:r>
-              <a:rPr lang="en-US" sz="1500" dirty="0">
+              <a:rPr lang="en-US" sz="1350" dirty="0">
                 <a:solidFill>
-                  <a:srgbClr val="FFD9D9"/>
+                  <a:srgbClr val="836A68"/>
                 </a:solidFill>
                 <a:latin typeface="Calibri" pitchFamily="34" charset="0"/>
                 <a:ea typeface="Calibri" pitchFamily="34" charset="-122"/>
@@ -3902,7 +3982,7 @@
               </a:rPr>
               <a:t>What happens to a measurement before any 'AI' ever sees it. Identical for both models.</a:t>
             </a:r>
-            <a:endParaRPr lang="en-US" sz="1500" dirty="0"/>
+            <a:endParaRPr lang="en-US" sz="1350" dirty="0"/>
           </a:p>
         </p:txBody>
       </p:sp>
@@ -4002,17 +4082,17 @@
               <a:buNone/>
             </a:pPr>
             <a:r>
-              <a:rPr lang="en-US" sz="2600" b="1" dirty="0">
+              <a:rPr lang="en-US" sz="2500" b="1" dirty="0">
                 <a:solidFill>
-                  <a:srgbClr val="2B2B2B"/>
+                  <a:srgbClr val="2A1618"/>
                 </a:solidFill>
-                <a:latin typeface="Calibri" pitchFamily="34" charset="0"/>
-                <a:ea typeface="Calibri" pitchFamily="34" charset="-122"/>
-                <a:cs typeface="Calibri" pitchFamily="34" charset="-120"/>
+                <a:latin typeface="Cambria" pitchFamily="34" charset="0"/>
+                <a:ea typeface="Cambria" pitchFamily="34" charset="-122"/>
+                <a:cs typeface="Cambria" pitchFamily="34" charset="-120"/>
               </a:rPr>
               <a:t>Four steps from raw sweep to model input</a:t>
             </a:r>
-            <a:endParaRPr lang="en-US" sz="2600" dirty="0"/>
+            <a:endParaRPr lang="en-US" sz="2500" dirty="0"/>
           </a:p>
         </p:txBody>
       </p:sp>
@@ -4200,17 +4280,17 @@
               <a:buNone/>
             </a:pPr>
             <a:r>
-              <a:rPr lang="en-US" sz="2600" b="1" dirty="0">
+              <a:rPr lang="en-US" sz="2500" b="1" dirty="0">
                 <a:solidFill>
-                  <a:srgbClr val="2B2B2B"/>
+                  <a:srgbClr val="2A1618"/>
                 </a:solidFill>
-                <a:latin typeface="Calibri" pitchFamily="34" charset="0"/>
-                <a:ea typeface="Calibri" pitchFamily="34" charset="-122"/>
-                <a:cs typeface="Calibri" pitchFamily="34" charset="-120"/>
+                <a:latin typeface="Cambria" pitchFamily="34" charset="0"/>
+                <a:ea typeface="Cambria" pitchFamily="34" charset="-122"/>
+                <a:cs typeface="Cambria" pitchFamily="34" charset="-120"/>
               </a:rPr>
               <a:t>Three input representations</a:t>
             </a:r>
-            <a:endParaRPr lang="en-US" sz="2600" dirty="0"/>
+            <a:endParaRPr lang="en-US" sz="2500" dirty="0"/>
           </a:p>
         </p:txBody>
       </p:sp>
@@ -4883,17 +4963,17 @@
               <a:buNone/>
             </a:pPr>
             <a:r>
-              <a:rPr lang="en-US" sz="2600" b="1" dirty="0">
+              <a:rPr lang="en-US" sz="2500" b="1" dirty="0">
                 <a:solidFill>
-                  <a:srgbClr val="2B2B2B"/>
+                  <a:srgbClr val="2A1618"/>
                 </a:solidFill>
-                <a:latin typeface="Calibri" pitchFamily="34" charset="0"/>
-                <a:ea typeface="Calibri" pitchFamily="34" charset="-122"/>
-                <a:cs typeface="Calibri" pitchFamily="34" charset="-120"/>
+                <a:latin typeface="Cambria" pitchFamily="34" charset="0"/>
+                <a:ea typeface="Cambria" pitchFamily="34" charset="-122"/>
+                <a:cs typeface="Cambria" pitchFamily="34" charset="-120"/>
               </a:rPr>
               <a:t>How we score: Leave-One-Session-Out</a:t>
             </a:r>
-            <a:endParaRPr lang="en-US" sz="2600" dirty="0"/>
+            <a:endParaRPr lang="en-US" sz="2500" dirty="0"/>
           </a:p>
         </p:txBody>
       </p:sp>
@@ -5102,17 +5182,17 @@
               <a:buNone/>
             </a:pPr>
             <a:r>
-              <a:rPr lang="en-US" sz="2600" b="1" dirty="0">
+              <a:rPr lang="en-US" sz="2500" b="1" dirty="0">
                 <a:solidFill>
-                  <a:srgbClr val="2B2B2B"/>
+                  <a:srgbClr val="2A1618"/>
                 </a:solidFill>
-                <a:latin typeface="Calibri" pitchFamily="34" charset="0"/>
-                <a:ea typeface="Calibri" pitchFamily="34" charset="-122"/>
-                <a:cs typeface="Calibri" pitchFamily="34" charset="-120"/>
+                <a:latin typeface="Cambria" pitchFamily="34" charset="0"/>
+                <a:ea typeface="Cambria" pitchFamily="34" charset="-122"/>
+                <a:cs typeface="Cambria" pitchFamily="34" charset="-120"/>
               </a:rPr>
               <a:t>Three phantom setups, increasing difficulty</a:t>
             </a:r>
-            <a:endParaRPr lang="en-US" sz="2600" dirty="0"/>
+            <a:endParaRPr lang="en-US" sz="2500" dirty="0"/>
           </a:p>
         </p:txBody>
       </p:sp>
@@ -5487,7 +5567,7 @@
     <p:bg>
       <p:bgPr>
         <a:solidFill>
-          <a:srgbClr val="BE0000"/>
+          <a:srgbClr val="FDF8F6"/>
         </a:solidFill>
       </p:bgPr>
     </p:bg>
@@ -5507,14 +5587,54 @@
       </p:grpSpPr>
       <p:sp>
         <p:nvSpPr>
-          <p:cNvPr id="2" name="Text 0"/>
+          <p:cNvPr id="2" name="Shape 0"/>
           <p:cNvSpPr/>
           <p:nvPr/>
         </p:nvSpPr>
         <p:spPr>
           <a:xfrm>
-            <a:off x="640080" y="1600200"/>
-            <a:ext cx="7863840" cy="365760"/>
+            <a:off x="0" y="0"/>
+            <a:ext cx="9144000" cy="182880"/>
+          </a:xfrm>
+          <a:prstGeom prst="rect">
+            <a:avLst/>
+          </a:prstGeom>
+          <a:solidFill>
+            <a:srgbClr val="BE0000"/>
+          </a:solidFill>
+          <a:ln/>
+        </p:spPr>
+      </p:sp>
+      <p:sp>
+        <p:nvSpPr>
+          <p:cNvPr id="3" name="Shape 1"/>
+          <p:cNvSpPr/>
+          <p:nvPr/>
+        </p:nvSpPr>
+        <p:spPr>
+          <a:xfrm>
+            <a:off x="621792" y="1847088"/>
+            <a:ext cx="64008" cy="1051560"/>
+          </a:xfrm>
+          <a:prstGeom prst="rect">
+            <a:avLst/>
+          </a:prstGeom>
+          <a:solidFill>
+            <a:srgbClr val="BE0000"/>
+          </a:solidFill>
+          <a:ln/>
+        </p:spPr>
+      </p:sp>
+      <p:sp>
+        <p:nvSpPr>
+          <p:cNvPr id="4" name="Text 2"/>
+          <p:cNvSpPr/>
+          <p:nvPr/>
+        </p:nvSpPr>
+        <p:spPr>
+          <a:xfrm>
+            <a:off x="841248" y="1874520"/>
+            <a:ext cx="7680960" cy="320040"/>
           </a:xfrm>
           <a:prstGeom prst="rect">
             <a:avLst/>
@@ -5530,9 +5650,9 @@
               <a:buNone/>
             </a:pPr>
             <a:r>
-              <a:rPr lang="en-US" sz="1400" b="1" spc="300" kern="0" dirty="0">
+              <a:rPr lang="en-US" sz="1250" b="1" spc="300" kern="0" dirty="0">
                 <a:solidFill>
-                  <a:srgbClr val="F5B8B8"/>
+                  <a:srgbClr val="BE0000"/>
                 </a:solidFill>
                 <a:latin typeface="Calibri" pitchFamily="34" charset="0"/>
                 <a:ea typeface="Calibri" pitchFamily="34" charset="-122"/>
@@ -5540,20 +5660,20 @@
               </a:rPr>
               <a:t>PART 3</a:t>
             </a:r>
-            <a:endParaRPr lang="en-US" sz="1400" dirty="0"/>
+            <a:endParaRPr lang="en-US" sz="1250" dirty="0"/>
           </a:p>
         </p:txBody>
       </p:sp>
       <p:sp>
         <p:nvSpPr>
-          <p:cNvPr id="3" name="Text 1"/>
+          <p:cNvPr id="5" name="Text 3"/>
           <p:cNvSpPr/>
           <p:nvPr/>
         </p:nvSpPr>
         <p:spPr>
           <a:xfrm>
-            <a:off x="640080" y="1965960"/>
-            <a:ext cx="7863840" cy="914400"/>
+            <a:off x="841248" y="2212848"/>
+            <a:ext cx="7680960" cy="685800"/>
           </a:xfrm>
           <a:prstGeom prst="rect">
             <a:avLst/>
@@ -5569,30 +5689,30 @@
               <a:buNone/>
             </a:pPr>
             <a:r>
-              <a:rPr lang="en-US" sz="4000" b="1" dirty="0">
+              <a:rPr lang="en-US" sz="3300" b="1" dirty="0">
                 <a:solidFill>
-                  <a:srgbClr val="FFFFFF"/>
+                  <a:srgbClr val="2A1618"/>
                 </a:solidFill>
-                <a:latin typeface="Calibri" pitchFamily="34" charset="0"/>
-                <a:ea typeface="Calibri" pitchFamily="34" charset="-122"/>
-                <a:cs typeface="Calibri" pitchFamily="34" charset="-120"/>
+                <a:latin typeface="Cambria" pitchFamily="34" charset="0"/>
+                <a:ea typeface="Cambria" pitchFamily="34" charset="-122"/>
+                <a:cs typeface="Cambria" pitchFamily="34" charset="-120"/>
               </a:rPr>
               <a:t>Results</a:t>
             </a:r>
-            <a:endParaRPr lang="en-US" sz="4000" dirty="0"/>
+            <a:endParaRPr lang="en-US" sz="3300" dirty="0"/>
           </a:p>
         </p:txBody>
       </p:sp>
       <p:sp>
         <p:nvSpPr>
-          <p:cNvPr id="4" name="Text 2"/>
+          <p:cNvPr id="6" name="Text 4"/>
           <p:cNvSpPr/>
           <p:nvPr/>
         </p:nvSpPr>
         <p:spPr>
           <a:xfrm>
-            <a:off x="640080" y="2971800"/>
-            <a:ext cx="7863840" cy="822960"/>
+            <a:off x="841248" y="2999232"/>
+            <a:ext cx="7498080" cy="731520"/>
           </a:xfrm>
           <a:prstGeom prst="rect">
             <a:avLst/>
@@ -5608,9 +5728,9 @@
               <a:buNone/>
             </a:pPr>
             <a:r>
-              <a:rPr lang="en-US" sz="1500" dirty="0">
+              <a:rPr lang="en-US" sz="1350" dirty="0">
                 <a:solidFill>
-                  <a:srgbClr val="FFD9D9"/>
+                  <a:srgbClr val="836A68"/>
                 </a:solidFill>
                 <a:latin typeface="Calibri" pitchFamily="34" charset="0"/>
                 <a:ea typeface="Calibri" pitchFamily="34" charset="-122"/>
@@ -5618,7 +5738,7 @@
               </a:rPr>
               <a:t>Per-position vote accuracy (%) under LOSO · identical raw inputs (mag + phase) · chance = 2–3%</a:t>
             </a:r>
-            <a:endParaRPr lang="en-US" sz="1500" dirty="0"/>
+            <a:endParaRPr lang="en-US" sz="1350" dirty="0"/>
           </a:p>
         </p:txBody>
       </p:sp>
@@ -5718,17 +5838,17 @@
               <a:buNone/>
             </a:pPr>
             <a:r>
-              <a:rPr lang="en-US" sz="2600" b="1" dirty="0">
+              <a:rPr lang="en-US" sz="2500" b="1" dirty="0">
                 <a:solidFill>
-                  <a:srgbClr val="2B2B2B"/>
+                  <a:srgbClr val="2A1618"/>
                 </a:solidFill>
-                <a:latin typeface="Calibri" pitchFamily="34" charset="0"/>
-                <a:ea typeface="Calibri" pitchFamily="34" charset="-122"/>
-                <a:cs typeface="Calibri" pitchFamily="34" charset="-120"/>
+                <a:latin typeface="Cambria" pitchFamily="34" charset="0"/>
+                <a:ea typeface="Cambria" pitchFamily="34" charset="-122"/>
+                <a:cs typeface="Cambria" pitchFamily="34" charset="-120"/>
               </a:rPr>
               <a:t>All 4 antennas: full S-parameters (16)</a:t>
             </a:r>
-            <a:endParaRPr lang="en-US" sz="2600" dirty="0"/>
+            <a:endParaRPr lang="en-US" sz="2500" dirty="0"/>
           </a:p>
         </p:txBody>
       </p:sp>
@@ -7334,17 +7454,17 @@
               <a:buNone/>
             </a:pPr>
             <a:r>
-              <a:rPr lang="en-US" sz="2600" b="1" dirty="0">
+              <a:rPr lang="en-US" sz="2500" b="1" dirty="0">
                 <a:solidFill>
-                  <a:srgbClr val="2B2B2B"/>
+                  <a:srgbClr val="2A1618"/>
                 </a:solidFill>
-                <a:latin typeface="Calibri" pitchFamily="34" charset="0"/>
-                <a:ea typeface="Calibri" pitchFamily="34" charset="-122"/>
-                <a:cs typeface="Calibri" pitchFamily="34" charset="-120"/>
+                <a:latin typeface="Cambria" pitchFamily="34" charset="0"/>
+                <a:ea typeface="Cambria" pitchFamily="34" charset="-122"/>
+                <a:cs typeface="Cambria" pitchFamily="34" charset="-120"/>
               </a:rPr>
               <a:t>Error Locations: all 4 antennas</a:t>
             </a:r>
-            <a:endParaRPr lang="en-US" sz="2600" dirty="0"/>
+            <a:endParaRPr lang="en-US" sz="2500" dirty="0"/>
           </a:p>
         </p:txBody>
       </p:sp>
@@ -7588,17 +7708,17 @@
               <a:buNone/>
             </a:pPr>
             <a:r>
-              <a:rPr lang="en-US" sz="2600" b="1" dirty="0">
+              <a:rPr lang="en-US" sz="2500" b="1" dirty="0">
                 <a:solidFill>
-                  <a:srgbClr val="2B2B2B"/>
+                  <a:srgbClr val="2A1618"/>
                 </a:solidFill>
-                <a:latin typeface="Calibri" pitchFamily="34" charset="0"/>
-                <a:ea typeface="Calibri" pitchFamily="34" charset="-122"/>
-                <a:cs typeface="Calibri" pitchFamily="34" charset="-120"/>
+                <a:latin typeface="Cambria" pitchFamily="34" charset="0"/>
+                <a:ea typeface="Cambria" pitchFamily="34" charset="-122"/>
+                <a:cs typeface="Cambria" pitchFamily="34" charset="-120"/>
               </a:rPr>
               <a:t>All 4 antennas: reflection only (S11, S22, S33, S44)</a:t>
             </a:r>
-            <a:endParaRPr lang="en-US" sz="2600" dirty="0"/>
+            <a:endParaRPr lang="en-US" sz="2500" dirty="0"/>
           </a:p>
         </p:txBody>
       </p:sp>
@@ -9204,17 +9324,17 @@
               <a:buNone/>
             </a:pPr>
             <a:r>
-              <a:rPr lang="en-US" sz="2600" b="1" dirty="0">
+              <a:rPr lang="en-US" sz="2500" b="1" dirty="0">
                 <a:solidFill>
-                  <a:srgbClr val="2B2B2B"/>
+                  <a:srgbClr val="2A1618"/>
                 </a:solidFill>
-                <a:latin typeface="Calibri" pitchFamily="34" charset="0"/>
-                <a:ea typeface="Calibri" pitchFamily="34" charset="-122"/>
-                <a:cs typeface="Calibri" pitchFamily="34" charset="-120"/>
+                <a:latin typeface="Cambria" pitchFamily="34" charset="0"/>
+                <a:ea typeface="Cambria" pitchFamily="34" charset="-122"/>
+                <a:cs typeface="Cambria" pitchFamily="34" charset="-120"/>
               </a:rPr>
               <a:t>Error Locations: all 4 antennas, reflection only</a:t>
             </a:r>
-            <a:endParaRPr lang="en-US" sz="2600" dirty="0"/>
+            <a:endParaRPr lang="en-US" sz="2500" dirty="0"/>
           </a:p>
         </p:txBody>
       </p:sp>
@@ -9377,17 +9497,17 @@
               <a:buNone/>
             </a:pPr>
             <a:r>
-              <a:rPr lang="en-US" sz="2600" b="1" dirty="0">
+              <a:rPr lang="en-US" sz="2500" b="1" dirty="0">
                 <a:solidFill>
-                  <a:srgbClr val="2B2B2B"/>
+                  <a:srgbClr val="2A1618"/>
                 </a:solidFill>
-                <a:latin typeface="Calibri" pitchFamily="34" charset="0"/>
-                <a:ea typeface="Calibri" pitchFamily="34" charset="-122"/>
-                <a:cs typeface="Calibri" pitchFamily="34" charset="-120"/>
+                <a:latin typeface="Cambria" pitchFamily="34" charset="0"/>
+                <a:ea typeface="Cambria" pitchFamily="34" charset="-122"/>
+                <a:cs typeface="Cambria" pitchFamily="34" charset="-120"/>
               </a:rPr>
               <a:t>Find a hidden tumor inside a breast phantom</a:t>
             </a:r>
-            <a:endParaRPr lang="en-US" sz="2600" dirty="0"/>
+            <a:endParaRPr lang="en-US" sz="2500" dirty="0"/>
           </a:p>
         </p:txBody>
       </p:sp>
@@ -9677,17 +9797,17 @@
               <a:buNone/>
             </a:pPr>
             <a:r>
-              <a:rPr lang="en-US" sz="2600" b="1" dirty="0">
+              <a:rPr lang="en-US" sz="2500" b="1" dirty="0">
                 <a:solidFill>
-                  <a:srgbClr val="2B2B2B"/>
+                  <a:srgbClr val="2A1618"/>
                 </a:solidFill>
-                <a:latin typeface="Calibri" pitchFamily="34" charset="0"/>
-                <a:ea typeface="Calibri" pitchFamily="34" charset="-122"/>
-                <a:cs typeface="Calibri" pitchFamily="34" charset="-120"/>
+                <a:latin typeface="Cambria" pitchFamily="34" charset="0"/>
+                <a:ea typeface="Cambria" pitchFamily="34" charset="-122"/>
+                <a:cs typeface="Cambria" pitchFamily="34" charset="-120"/>
               </a:rPr>
               <a:t>2 antennas (ports 1 &amp; 3): full S-parameters</a:t>
             </a:r>
-            <a:endParaRPr lang="en-US" sz="2600" dirty="0"/>
+            <a:endParaRPr lang="en-US" sz="2500" dirty="0"/>
           </a:p>
         </p:txBody>
       </p:sp>
@@ -11293,17 +11413,17 @@
               <a:buNone/>
             </a:pPr>
             <a:r>
-              <a:rPr lang="en-US" sz="2600" b="1" dirty="0">
+              <a:rPr lang="en-US" sz="2500" b="1" dirty="0">
                 <a:solidFill>
-                  <a:srgbClr val="2B2B2B"/>
+                  <a:srgbClr val="2A1618"/>
                 </a:solidFill>
-                <a:latin typeface="Calibri" pitchFamily="34" charset="0"/>
-                <a:ea typeface="Calibri" pitchFamily="34" charset="-122"/>
-                <a:cs typeface="Calibri" pitchFamily="34" charset="-120"/>
+                <a:latin typeface="Cambria" pitchFamily="34" charset="0"/>
+                <a:ea typeface="Cambria" pitchFamily="34" charset="-122"/>
+                <a:cs typeface="Cambria" pitchFamily="34" charset="-120"/>
               </a:rPr>
               <a:t>Error Locations: 2 antennas (1 &amp; 3)</a:t>
             </a:r>
-            <a:endParaRPr lang="en-US" sz="2600" dirty="0"/>
+            <a:endParaRPr lang="en-US" sz="2500" dirty="0"/>
           </a:p>
         </p:txBody>
       </p:sp>
@@ -11466,17 +11586,17 @@
               <a:buNone/>
             </a:pPr>
             <a:r>
-              <a:rPr lang="en-US" sz="2600" b="1" dirty="0">
+              <a:rPr lang="en-US" sz="2500" b="1" dirty="0">
                 <a:solidFill>
-                  <a:srgbClr val="2B2B2B"/>
+                  <a:srgbClr val="2A1618"/>
                 </a:solidFill>
-                <a:latin typeface="Calibri" pitchFamily="34" charset="0"/>
-                <a:ea typeface="Calibri" pitchFamily="34" charset="-122"/>
-                <a:cs typeface="Calibri" pitchFamily="34" charset="-120"/>
+                <a:latin typeface="Cambria" pitchFamily="34" charset="0"/>
+                <a:ea typeface="Cambria" pitchFamily="34" charset="-122"/>
+                <a:cs typeface="Cambria" pitchFamily="34" charset="-120"/>
               </a:rPr>
               <a:t>2 antennas (1 &amp; 3): reflection only (S11, S33)</a:t>
             </a:r>
-            <a:endParaRPr lang="en-US" sz="2600" dirty="0"/>
+            <a:endParaRPr lang="en-US" sz="2500" dirty="0"/>
           </a:p>
         </p:txBody>
       </p:sp>
@@ -13082,17 +13202,17 @@
               <a:buNone/>
             </a:pPr>
             <a:r>
-              <a:rPr lang="en-US" sz="2600" b="1" dirty="0">
+              <a:rPr lang="en-US" sz="2500" b="1" dirty="0">
                 <a:solidFill>
-                  <a:srgbClr val="2B2B2B"/>
+                  <a:srgbClr val="2A1618"/>
                 </a:solidFill>
-                <a:latin typeface="Calibri" pitchFamily="34" charset="0"/>
-                <a:ea typeface="Calibri" pitchFamily="34" charset="-122"/>
-                <a:cs typeface="Calibri" pitchFamily="34" charset="-120"/>
+                <a:latin typeface="Cambria" pitchFamily="34" charset="0"/>
+                <a:ea typeface="Cambria" pitchFamily="34" charset="-122"/>
+                <a:cs typeface="Cambria" pitchFamily="34" charset="-120"/>
               </a:rPr>
               <a:t>Error Locations: 2 antennas (1 &amp; 3), reflection only</a:t>
             </a:r>
-            <a:endParaRPr lang="en-US" sz="2600" dirty="0"/>
+            <a:endParaRPr lang="en-US" sz="2500" dirty="0"/>
           </a:p>
         </p:txBody>
       </p:sp>
@@ -13255,17 +13375,17 @@
               <a:buNone/>
             </a:pPr>
             <a:r>
-              <a:rPr lang="en-US" sz="2600" b="1" dirty="0">
+              <a:rPr lang="en-US" sz="2500" b="1" dirty="0">
                 <a:solidFill>
-                  <a:srgbClr val="2B2B2B"/>
+                  <a:srgbClr val="2A1618"/>
                 </a:solidFill>
-                <a:latin typeface="Calibri" pitchFamily="34" charset="0"/>
-                <a:ea typeface="Calibri" pitchFamily="34" charset="-122"/>
-                <a:cs typeface="Calibri" pitchFamily="34" charset="-120"/>
+                <a:latin typeface="Cambria" pitchFamily="34" charset="0"/>
+                <a:ea typeface="Cambria" pitchFamily="34" charset="-122"/>
+                <a:cs typeface="Cambria" pitchFamily="34" charset="-120"/>
               </a:rPr>
               <a:t>1 antenna: S11 only</a:t>
             </a:r>
-            <a:endParaRPr lang="en-US" sz="2600" dirty="0"/>
+            <a:endParaRPr lang="en-US" sz="2500" dirty="0"/>
           </a:p>
         </p:txBody>
       </p:sp>
@@ -14871,17 +14991,17 @@
               <a:buNone/>
             </a:pPr>
             <a:r>
-              <a:rPr lang="en-US" sz="2600" b="1" dirty="0">
+              <a:rPr lang="en-US" sz="2500" b="1" dirty="0">
                 <a:solidFill>
-                  <a:srgbClr val="2B2B2B"/>
+                  <a:srgbClr val="2A1618"/>
                 </a:solidFill>
-                <a:latin typeface="Calibri" pitchFamily="34" charset="0"/>
-                <a:ea typeface="Calibri" pitchFamily="34" charset="-122"/>
-                <a:cs typeface="Calibri" pitchFamily="34" charset="-120"/>
+                <a:latin typeface="Cambria" pitchFamily="34" charset="0"/>
+                <a:ea typeface="Cambria" pitchFamily="34" charset="-122"/>
+                <a:cs typeface="Cambria" pitchFamily="34" charset="-120"/>
               </a:rPr>
               <a:t>Error Locations: 1 antenna (S11)</a:t>
             </a:r>
-            <a:endParaRPr lang="en-US" sz="2600" dirty="0"/>
+            <a:endParaRPr lang="en-US" sz="2500" dirty="0"/>
           </a:p>
         </p:txBody>
       </p:sp>
@@ -14962,7 +15082,7 @@
     <p:bg>
       <p:bgPr>
         <a:solidFill>
-          <a:srgbClr val="BE0000"/>
+          <a:srgbClr val="FDF8F6"/>
         </a:solidFill>
       </p:bgPr>
     </p:bg>
@@ -14982,14 +15102,54 @@
       </p:grpSpPr>
       <p:sp>
         <p:nvSpPr>
-          <p:cNvPr id="2" name="Text 0"/>
+          <p:cNvPr id="2" name="Shape 0"/>
           <p:cNvSpPr/>
           <p:nvPr/>
         </p:nvSpPr>
         <p:spPr>
           <a:xfrm>
-            <a:off x="640080" y="1600200"/>
-            <a:ext cx="7863840" cy="365760"/>
+            <a:off x="0" y="0"/>
+            <a:ext cx="9144000" cy="182880"/>
+          </a:xfrm>
+          <a:prstGeom prst="rect">
+            <a:avLst/>
+          </a:prstGeom>
+          <a:solidFill>
+            <a:srgbClr val="BE0000"/>
+          </a:solidFill>
+          <a:ln/>
+        </p:spPr>
+      </p:sp>
+      <p:sp>
+        <p:nvSpPr>
+          <p:cNvPr id="3" name="Shape 1"/>
+          <p:cNvSpPr/>
+          <p:nvPr/>
+        </p:nvSpPr>
+        <p:spPr>
+          <a:xfrm>
+            <a:off x="621792" y="1847088"/>
+            <a:ext cx="64008" cy="1051560"/>
+          </a:xfrm>
+          <a:prstGeom prst="rect">
+            <a:avLst/>
+          </a:prstGeom>
+          <a:solidFill>
+            <a:srgbClr val="BE0000"/>
+          </a:solidFill>
+          <a:ln/>
+        </p:spPr>
+      </p:sp>
+      <p:sp>
+        <p:nvSpPr>
+          <p:cNvPr id="4" name="Text 2"/>
+          <p:cNvSpPr/>
+          <p:nvPr/>
+        </p:nvSpPr>
+        <p:spPr>
+          <a:xfrm>
+            <a:off x="841248" y="1874520"/>
+            <a:ext cx="7680960" cy="320040"/>
           </a:xfrm>
           <a:prstGeom prst="rect">
             <a:avLst/>
@@ -15005,9 +15165,9 @@
               <a:buNone/>
             </a:pPr>
             <a:r>
-              <a:rPr lang="en-US" sz="1400" b="1" spc="300" kern="0" dirty="0">
+              <a:rPr lang="en-US" sz="1250" b="1" spc="300" kern="0" dirty="0">
                 <a:solidFill>
-                  <a:srgbClr val="F5B8B8"/>
+                  <a:srgbClr val="BE0000"/>
                 </a:solidFill>
                 <a:latin typeface="Calibri" pitchFamily="34" charset="0"/>
                 <a:ea typeface="Calibri" pitchFamily="34" charset="-122"/>
@@ -15015,20 +15175,20 @@
               </a:rPr>
               <a:t>PART 4</a:t>
             </a:r>
-            <a:endParaRPr lang="en-US" sz="1400" dirty="0"/>
+            <a:endParaRPr lang="en-US" sz="1250" dirty="0"/>
           </a:p>
         </p:txBody>
       </p:sp>
       <p:sp>
         <p:nvSpPr>
-          <p:cNvPr id="3" name="Text 1"/>
+          <p:cNvPr id="5" name="Text 3"/>
           <p:cNvSpPr/>
           <p:nvPr/>
         </p:nvSpPr>
         <p:spPr>
           <a:xfrm>
-            <a:off x="640080" y="1965960"/>
-            <a:ext cx="7863840" cy="914400"/>
+            <a:off x="841248" y="2212848"/>
+            <a:ext cx="7680960" cy="685800"/>
           </a:xfrm>
           <a:prstGeom prst="rect">
             <a:avLst/>
@@ -15044,30 +15204,30 @@
               <a:buNone/>
             </a:pPr>
             <a:r>
-              <a:rPr lang="en-US" sz="4000" b="1" dirty="0">
+              <a:rPr lang="en-US" sz="3300" b="1" dirty="0">
                 <a:solidFill>
-                  <a:srgbClr val="FFFFFF"/>
+                  <a:srgbClr val="2A1618"/>
                 </a:solidFill>
-                <a:latin typeface="Calibri" pitchFamily="34" charset="0"/>
-                <a:ea typeface="Calibri" pitchFamily="34" charset="-122"/>
-                <a:cs typeface="Calibri" pitchFamily="34" charset="-120"/>
+                <a:latin typeface="Cambria" pitchFamily="34" charset="0"/>
+                <a:ea typeface="Cambria" pitchFamily="34" charset="-122"/>
+                <a:cs typeface="Cambria" pitchFamily="34" charset="-120"/>
               </a:rPr>
               <a:t>Physics-informed features</a:t>
             </a:r>
-            <a:endParaRPr lang="en-US" sz="4000" dirty="0"/>
+            <a:endParaRPr lang="en-US" sz="3300" dirty="0"/>
           </a:p>
         </p:txBody>
       </p:sp>
       <p:sp>
         <p:nvSpPr>
-          <p:cNvPr id="4" name="Text 2"/>
+          <p:cNvPr id="6" name="Text 4"/>
           <p:cNvSpPr/>
           <p:nvPr/>
         </p:nvSpPr>
         <p:spPr>
           <a:xfrm>
-            <a:off x="640080" y="2971800"/>
-            <a:ext cx="7863840" cy="822960"/>
+            <a:off x="841248" y="2999232"/>
+            <a:ext cx="7498080" cy="731520"/>
           </a:xfrm>
           <a:prstGeom prst="rect">
             <a:avLst/>
@@ -15083,9 +15243,9 @@
               <a:buNone/>
             </a:pPr>
             <a:r>
-              <a:rPr lang="en-US" sz="1500" dirty="0">
+              <a:rPr lang="en-US" sz="1350" dirty="0">
                 <a:solidFill>
-                  <a:srgbClr val="FFD9D9"/>
+                  <a:srgbClr val="836A68"/>
                 </a:solidFill>
                 <a:latin typeface="Calibri" pitchFamily="34" charset="0"/>
                 <a:ea typeface="Calibri" pitchFamily="34" charset="-122"/>
@@ -15093,7 +15253,7 @@
               </a:rPr>
               <a:t>Squeezing more out of the same measurement: no new hardware, no new data collection</a:t>
             </a:r>
-            <a:endParaRPr lang="en-US" sz="1500" dirty="0"/>
+            <a:endParaRPr lang="en-US" sz="1350" dirty="0"/>
           </a:p>
         </p:txBody>
       </p:sp>
@@ -15193,17 +15353,17 @@
               <a:buNone/>
             </a:pPr>
             <a:r>
-              <a:rPr lang="en-US" sz="2600" b="1" dirty="0">
+              <a:rPr lang="en-US" sz="2500" b="1" dirty="0">
                 <a:solidFill>
-                  <a:srgbClr val="2B2B2B"/>
+                  <a:srgbClr val="2A1618"/>
                 </a:solidFill>
-                <a:latin typeface="Calibri" pitchFamily="34" charset="0"/>
-                <a:ea typeface="Calibri" pitchFamily="34" charset="-122"/>
-                <a:cs typeface="Calibri" pitchFamily="34" charset="-120"/>
+                <a:latin typeface="Cambria" pitchFamily="34" charset="0"/>
+                <a:ea typeface="Cambria" pitchFamily="34" charset="-122"/>
+                <a:cs typeface="Cambria" pitchFamily="34" charset="-120"/>
               </a:rPr>
               <a:t>One complex measurement, five physical views</a:t>
             </a:r>
-            <a:endParaRPr lang="en-US" sz="2600" dirty="0"/>
+            <a:endParaRPr lang="en-US" sz="2500" dirty="0"/>
           </a:p>
         </p:txBody>
       </p:sp>
@@ -15471,17 +15631,17 @@
               <a:buNone/>
             </a:pPr>
             <a:r>
-              <a:rPr lang="en-US" sz="2600" b="1" dirty="0">
+              <a:rPr lang="en-US" sz="2500" b="1" dirty="0">
                 <a:solidFill>
-                  <a:srgbClr val="2B2B2B"/>
+                  <a:srgbClr val="2A1618"/>
                 </a:solidFill>
-                <a:latin typeface="Calibri" pitchFamily="34" charset="0"/>
-                <a:ea typeface="Calibri" pitchFamily="34" charset="-122"/>
-                <a:cs typeface="Calibri" pitchFamily="34" charset="-120"/>
+                <a:latin typeface="Cambria" pitchFamily="34" charset="0"/>
+                <a:ea typeface="Cambria" pitchFamily="34" charset="-122"/>
+                <a:cs typeface="Cambria" pitchFamily="34" charset="-120"/>
               </a:rPr>
               <a:t>Same tests, physics inputs</a:t>
             </a:r>
-            <a:endParaRPr lang="en-US" sz="2600" dirty="0"/>
+            <a:endParaRPr lang="en-US" sz="2500" dirty="0"/>
           </a:p>
         </p:txBody>
       </p:sp>
@@ -18500,17 +18660,17 @@
               <a:buNone/>
             </a:pPr>
             <a:r>
-              <a:rPr lang="en-US" sz="2600" b="1" dirty="0">
+              <a:rPr lang="en-US" sz="2500" b="1" dirty="0">
                 <a:solidFill>
-                  <a:srgbClr val="2B2B2B"/>
+                  <a:srgbClr val="2A1618"/>
                 </a:solidFill>
-                <a:latin typeface="Calibri" pitchFamily="34" charset="0"/>
-                <a:ea typeface="Calibri" pitchFamily="34" charset="-122"/>
-                <a:cs typeface="Calibri" pitchFamily="34" charset="-120"/>
+                <a:latin typeface="Cambria" pitchFamily="34" charset="0"/>
+                <a:ea typeface="Cambria" pitchFamily="34" charset="-122"/>
+                <a:cs typeface="Cambria" pitchFamily="34" charset="-120"/>
               </a:rPr>
               <a:t>Reflection only + physics features</a:t>
             </a:r>
-            <a:endParaRPr lang="en-US" sz="2600" dirty="0"/>
+            <a:endParaRPr lang="en-US" sz="2500" dirty="0"/>
           </a:p>
         </p:txBody>
       </p:sp>
@@ -21556,17 +21716,17 @@
               <a:buNone/>
             </a:pPr>
             <a:r>
-              <a:rPr lang="en-US" sz="2600" b="1" dirty="0">
+              <a:rPr lang="en-US" sz="2500" b="1" dirty="0">
                 <a:solidFill>
-                  <a:srgbClr val="2B2B2B"/>
+                  <a:srgbClr val="2A1618"/>
                 </a:solidFill>
-                <a:latin typeface="Calibri" pitchFamily="34" charset="0"/>
-                <a:ea typeface="Calibri" pitchFamily="34" charset="-122"/>
-                <a:cs typeface="Calibri" pitchFamily="34" charset="-120"/>
+                <a:latin typeface="Cambria" pitchFamily="34" charset="0"/>
+                <a:ea typeface="Cambria" pitchFamily="34" charset="-122"/>
+                <a:cs typeface="Cambria" pitchFamily="34" charset="-120"/>
               </a:rPr>
               <a:t>Let a machine learn the fingerprint of every position</a:t>
             </a:r>
-            <a:endParaRPr lang="en-US" sz="2600" dirty="0"/>
+            <a:endParaRPr lang="en-US" sz="2500" dirty="0"/>
           </a:p>
         </p:txBody>
       </p:sp>
@@ -21963,17 +22123,17 @@
               <a:buNone/>
             </a:pPr>
             <a:r>
-              <a:rPr lang="en-US" sz="2600" b="1" dirty="0">
+              <a:rPr lang="en-US" sz="2500" b="1" dirty="0">
                 <a:solidFill>
-                  <a:srgbClr val="2B2B2B"/>
+                  <a:srgbClr val="2A1618"/>
                 </a:solidFill>
-                <a:latin typeface="Calibri" pitchFamily="34" charset="0"/>
-                <a:ea typeface="Calibri" pitchFamily="34" charset="-122"/>
-                <a:cs typeface="Calibri" pitchFamily="34" charset="-120"/>
+                <a:latin typeface="Cambria" pitchFamily="34" charset="0"/>
+                <a:ea typeface="Cambria" pitchFamily="34" charset="-122"/>
+                <a:cs typeface="Cambria" pitchFamily="34" charset="-120"/>
               </a:rPr>
               <a:t>What the derived features buy, and what TDR alone can't</a:t>
             </a:r>
-            <a:endParaRPr lang="en-US" sz="2600" dirty="0"/>
+            <a:endParaRPr lang="en-US" sz="2500" dirty="0"/>
           </a:p>
         </p:txBody>
       </p:sp>
@@ -22493,17 +22653,17 @@
               <a:buNone/>
             </a:pPr>
             <a:r>
-              <a:rPr lang="en-US" sz="2600" b="1" dirty="0">
+              <a:rPr lang="en-US" sz="2500" b="1" dirty="0">
                 <a:solidFill>
-                  <a:srgbClr val="2B2B2B"/>
+                  <a:srgbClr val="2A1618"/>
                 </a:solidFill>
-                <a:latin typeface="Calibri" pitchFamily="34" charset="0"/>
-                <a:ea typeface="Calibri" pitchFamily="34" charset="-122"/>
-                <a:cs typeface="Calibri" pitchFamily="34" charset="-120"/>
+                <a:latin typeface="Cambria" pitchFamily="34" charset="0"/>
+                <a:ea typeface="Cambria" pitchFamily="34" charset="-122"/>
+                <a:cs typeface="Cambria" pitchFamily="34" charset="-120"/>
               </a:rPr>
               <a:t>What we learned</a:t>
             </a:r>
-            <a:endParaRPr lang="en-US" sz="2600" dirty="0"/>
+            <a:endParaRPr lang="en-US" sz="2500" dirty="0"/>
           </a:p>
         </p:txBody>
       </p:sp>
@@ -23193,7 +23353,7 @@
     <p:bg>
       <p:bgPr>
         <a:solidFill>
-          <a:srgbClr val="BE0000"/>
+          <a:srgbClr val="FDF8F6"/>
         </a:solidFill>
       </p:bgPr>
     </p:bg>
@@ -23213,14 +23373,54 @@
       </p:grpSpPr>
       <p:sp>
         <p:nvSpPr>
-          <p:cNvPr id="2" name="Text 0"/>
+          <p:cNvPr id="2" name="Shape 0"/>
           <p:cNvSpPr/>
           <p:nvPr/>
         </p:nvSpPr>
         <p:spPr>
           <a:xfrm>
-            <a:off x="640080" y="1600200"/>
-            <a:ext cx="7863840" cy="365760"/>
+            <a:off x="0" y="0"/>
+            <a:ext cx="9144000" cy="182880"/>
+          </a:xfrm>
+          <a:prstGeom prst="rect">
+            <a:avLst/>
+          </a:prstGeom>
+          <a:solidFill>
+            <a:srgbClr val="BE0000"/>
+          </a:solidFill>
+          <a:ln/>
+        </p:spPr>
+      </p:sp>
+      <p:sp>
+        <p:nvSpPr>
+          <p:cNvPr id="3" name="Shape 1"/>
+          <p:cNvSpPr/>
+          <p:nvPr/>
+        </p:nvSpPr>
+        <p:spPr>
+          <a:xfrm>
+            <a:off x="621792" y="1847088"/>
+            <a:ext cx="64008" cy="1051560"/>
+          </a:xfrm>
+          <a:prstGeom prst="rect">
+            <a:avLst/>
+          </a:prstGeom>
+          <a:solidFill>
+            <a:srgbClr val="BE0000"/>
+          </a:solidFill>
+          <a:ln/>
+        </p:spPr>
+      </p:sp>
+      <p:sp>
+        <p:nvSpPr>
+          <p:cNvPr id="4" name="Text 2"/>
+          <p:cNvSpPr/>
+          <p:nvPr/>
+        </p:nvSpPr>
+        <p:spPr>
+          <a:xfrm>
+            <a:off x="841248" y="1874520"/>
+            <a:ext cx="7680960" cy="320040"/>
           </a:xfrm>
           <a:prstGeom prst="rect">
             <a:avLst/>
@@ -23236,9 +23436,9 @@
               <a:buNone/>
             </a:pPr>
             <a:r>
-              <a:rPr lang="en-US" sz="1400" b="1" spc="300" kern="0" dirty="0">
+              <a:rPr lang="en-US" sz="1250" b="1" spc="300" kern="0" dirty="0">
                 <a:solidFill>
-                  <a:srgbClr val="F5B8B8"/>
+                  <a:srgbClr val="BE0000"/>
                 </a:solidFill>
                 <a:latin typeface="Calibri" pitchFamily="34" charset="0"/>
                 <a:ea typeface="Calibri" pitchFamily="34" charset="-122"/>
@@ -23246,20 +23446,20 @@
               </a:rPr>
               <a:t>PART 1</a:t>
             </a:r>
-            <a:endParaRPr lang="en-US" sz="1400" dirty="0"/>
+            <a:endParaRPr lang="en-US" sz="1250" dirty="0"/>
           </a:p>
         </p:txBody>
       </p:sp>
       <p:sp>
         <p:nvSpPr>
-          <p:cNvPr id="3" name="Text 1"/>
+          <p:cNvPr id="5" name="Text 3"/>
           <p:cNvSpPr/>
           <p:nvPr/>
         </p:nvSpPr>
         <p:spPr>
           <a:xfrm>
-            <a:off x="640080" y="1965960"/>
-            <a:ext cx="7863840" cy="914400"/>
+            <a:off x="841248" y="2212848"/>
+            <a:ext cx="7680960" cy="685800"/>
           </a:xfrm>
           <a:prstGeom prst="rect">
             <a:avLst/>
@@ -23275,30 +23475,30 @@
               <a:buNone/>
             </a:pPr>
             <a:r>
-              <a:rPr lang="en-US" sz="4000" b="1" dirty="0">
+              <a:rPr lang="en-US" sz="3300" b="1" dirty="0">
                 <a:solidFill>
-                  <a:srgbClr val="FFFFFF"/>
+                  <a:srgbClr val="2A1618"/>
                 </a:solidFill>
-                <a:latin typeface="Calibri" pitchFamily="34" charset="0"/>
-                <a:ea typeface="Calibri" pitchFamily="34" charset="-122"/>
-                <a:cs typeface="Calibri" pitchFamily="34" charset="-120"/>
+                <a:latin typeface="Cambria" pitchFamily="34" charset="0"/>
+                <a:ea typeface="Cambria" pitchFamily="34" charset="-122"/>
+                <a:cs typeface="Cambria" pitchFamily="34" charset="-120"/>
               </a:rPr>
               <a:t>Methods</a:t>
             </a:r>
-            <a:endParaRPr lang="en-US" sz="4000" dirty="0"/>
+            <a:endParaRPr lang="en-US" sz="3300" dirty="0"/>
           </a:p>
         </p:txBody>
       </p:sp>
       <p:sp>
         <p:nvSpPr>
-          <p:cNvPr id="4" name="Text 2"/>
+          <p:cNvPr id="6" name="Text 4"/>
           <p:cNvSpPr/>
           <p:nvPr/>
         </p:nvSpPr>
         <p:spPr>
           <a:xfrm>
-            <a:off x="640080" y="2971800"/>
-            <a:ext cx="7863840" cy="822960"/>
+            <a:off x="841248" y="2999232"/>
+            <a:ext cx="7498080" cy="731520"/>
           </a:xfrm>
           <a:prstGeom prst="rect">
             <a:avLst/>
@@ -23314,9 +23514,9 @@
               <a:buNone/>
             </a:pPr>
             <a:r>
-              <a:rPr lang="en-US" sz="1500" dirty="0">
+              <a:rPr lang="en-US" sz="1350" dirty="0">
                 <a:solidFill>
-                  <a:srgbClr val="FFD9D9"/>
+                  <a:srgbClr val="836A68"/>
                 </a:solidFill>
                 <a:latin typeface="Calibri" pitchFamily="34" charset="0"/>
                 <a:ea typeface="Calibri" pitchFamily="34" charset="-122"/>
@@ -23324,7 +23524,7 @@
               </a:rPr>
               <a:t>The measurement, the two models, and how they differ</a:t>
             </a:r>
-            <a:endParaRPr lang="en-US" sz="1500" dirty="0"/>
+            <a:endParaRPr lang="en-US" sz="1350" dirty="0"/>
           </a:p>
         </p:txBody>
       </p:sp>
@@ -23424,17 +23624,17 @@
               <a:buNone/>
             </a:pPr>
             <a:r>
-              <a:rPr lang="en-US" sz="2600" b="1" dirty="0">
+              <a:rPr lang="en-US" sz="2500" b="1" dirty="0">
                 <a:solidFill>
-                  <a:srgbClr val="2B2B2B"/>
+                  <a:srgbClr val="2A1618"/>
                 </a:solidFill>
-                <a:latin typeface="Calibri" pitchFamily="34" charset="0"/>
-                <a:ea typeface="Calibri" pitchFamily="34" charset="-122"/>
-                <a:cs typeface="Calibri" pitchFamily="34" charset="-120"/>
+                <a:latin typeface="Cambria" pitchFamily="34" charset="0"/>
+                <a:ea typeface="Cambria" pitchFamily="34" charset="-122"/>
+                <a:cs typeface="Cambria" pitchFamily="34" charset="-120"/>
               </a:rPr>
               <a:t>The physical measurement</a:t>
             </a:r>
-            <a:endParaRPr lang="en-US" sz="2600" dirty="0"/>
+            <a:endParaRPr lang="en-US" sz="2500" dirty="0"/>
           </a:p>
         </p:txBody>
       </p:sp>
@@ -23724,17 +23924,17 @@
               <a:buNone/>
             </a:pPr>
             <a:r>
-              <a:rPr lang="en-US" sz="2600" b="1" dirty="0">
+              <a:rPr lang="en-US" sz="2500" b="1" dirty="0">
                 <a:solidFill>
-                  <a:srgbClr val="2B2B2B"/>
+                  <a:srgbClr val="2A1618"/>
                 </a:solidFill>
-                <a:latin typeface="Calibri" pitchFamily="34" charset="0"/>
-                <a:ea typeface="Calibri" pitchFamily="34" charset="-122"/>
-                <a:cs typeface="Calibri" pitchFamily="34" charset="-120"/>
+                <a:latin typeface="Cambria" pitchFamily="34" charset="0"/>
+                <a:ea typeface="Cambria" pitchFamily="34" charset="-122"/>
+                <a:cs typeface="Cambria" pitchFamily="34" charset="-120"/>
               </a:rPr>
               <a:t>Two ways to turn a measurement into a position</a:t>
             </a:r>
-            <a:endParaRPr lang="en-US" sz="2600" dirty="0"/>
+            <a:endParaRPr lang="en-US" sz="2500" dirty="0"/>
           </a:p>
         </p:txBody>
       </p:sp>
@@ -24225,17 +24425,17 @@
               <a:buNone/>
             </a:pPr>
             <a:r>
-              <a:rPr lang="en-US" sz="2600" b="1" dirty="0">
+              <a:rPr lang="en-US" sz="2500" b="1" dirty="0">
                 <a:solidFill>
-                  <a:srgbClr val="2B2B2B"/>
+                  <a:srgbClr val="2A1618"/>
                 </a:solidFill>
-                <a:latin typeface="Calibri" pitchFamily="34" charset="0"/>
-                <a:ea typeface="Calibri" pitchFamily="34" charset="-122"/>
-                <a:cs typeface="Calibri" pitchFamily="34" charset="-120"/>
+                <a:latin typeface="Cambria" pitchFamily="34" charset="0"/>
+                <a:ea typeface="Cambria" pitchFamily="34" charset="-122"/>
+                <a:cs typeface="Cambria" pitchFamily="34" charset="-120"/>
               </a:rPr>
               <a:t>The CNN</a:t>
             </a:r>
-            <a:endParaRPr lang="en-US" sz="2600" dirty="0"/>
+            <a:endParaRPr lang="en-US" sz="2500" dirty="0"/>
           </a:p>
         </p:txBody>
       </p:sp>
@@ -24465,17 +24665,17 @@
               <a:buNone/>
             </a:pPr>
             <a:r>
-              <a:rPr lang="en-US" sz="2600" b="1" dirty="0">
+              <a:rPr lang="en-US" sz="2500" b="1" dirty="0">
                 <a:solidFill>
-                  <a:srgbClr val="2B2B2B"/>
+                  <a:srgbClr val="2A1618"/>
                 </a:solidFill>
-                <a:latin typeface="Calibri" pitchFamily="34" charset="0"/>
-                <a:ea typeface="Calibri" pitchFamily="34" charset="-122"/>
-                <a:cs typeface="Calibri" pitchFamily="34" charset="-120"/>
+                <a:latin typeface="Cambria" pitchFamily="34" charset="0"/>
+                <a:ea typeface="Cambria" pitchFamily="34" charset="-122"/>
+                <a:cs typeface="Cambria" pitchFamily="34" charset="-120"/>
               </a:rPr>
               <a:t>The MLP</a:t>
             </a:r>
-            <a:endParaRPr lang="en-US" sz="2600" dirty="0"/>
+            <a:endParaRPr lang="en-US" sz="2500" dirty="0"/>
           </a:p>
         </p:txBody>
       </p:sp>
@@ -24705,17 +24905,17 @@
               <a:buNone/>
             </a:pPr>
             <a:r>
-              <a:rPr lang="en-US" sz="2600" b="1" dirty="0">
+              <a:rPr lang="en-US" sz="2500" b="1" dirty="0">
                 <a:solidFill>
-                  <a:srgbClr val="2B2B2B"/>
+                  <a:srgbClr val="2A1618"/>
                 </a:solidFill>
-                <a:latin typeface="Calibri" pitchFamily="34" charset="0"/>
-                <a:ea typeface="Calibri" pitchFamily="34" charset="-122"/>
-                <a:cs typeface="Calibri" pitchFamily="34" charset="-120"/>
+                <a:latin typeface="Cambria" pitchFamily="34" charset="0"/>
+                <a:ea typeface="Cambria" pitchFamily="34" charset="-122"/>
+                <a:cs typeface="Cambria" pitchFamily="34" charset="-120"/>
               </a:rPr>
               <a:t>CNN vs MLP: structural differences</a:t>
             </a:r>
-            <a:endParaRPr lang="en-US" sz="2600" dirty="0"/>
+            <a:endParaRPr lang="en-US" sz="2500" dirty="0"/>
           </a:p>
         </p:txBody>
       </p:sp>

</xml_diff>

<commit_message>
Analytical wording pass, Deck 1 reorder, un-squish depth figure
- removed casual/cheesy phrasing across all 3 decks (analytical tone)
- Deck 1 reordered to difficulty order (LOSO -> single-position -> cell) with
  bar charts before spatial plots
- Deck 2: slide 5 retitled "Same pattern on measured data"; removed the
  labeling-process / July10 notes; slide 11 beet wording rephrased
- Deck 3: removed "smooth/smoother" wording; slide 7 now explains what the two
  transfer plots show
- fig_depth_lopo caption wraps (fixed the horizontal squish)
- launched measured beet CNN LOSO (bkr0nwui2, CPU)

Co-Authored-By: Claude Opus 4.8 <noreply@anthropic.com>
</commit_message>
<xml_diff>
--- a/presentation/CNN_vs_MLP_Comparison.pptx
+++ b/presentation/CNN_vs_MLP_Comparison.pptx
@@ -22773,7 +22773,7 @@
                 <a:ea typeface="Calibri" pitchFamily="34" charset="-122"/>
                 <a:cs typeface="Calibri" pitchFamily="34" charset="-120"/>
               </a:rPr>
-              <a:t>On matched inputs the CNN ties easy cases and wins hard ones by up to 17 points.</a:t>
+              <a:t>On matched inputs the CNN ties easy cases and wins hard ones by up to 17 points, at ~10x the training cost.</a:t>
             </a:r>
             <a:endParaRPr lang="en-US" sz="1150" dirty="0"/>
           </a:p>
@@ -24471,8 +24471,8 @@
         </p:nvSpPr>
         <p:spPr>
           <a:xfrm>
-            <a:off x="457200" y="3246120"/>
-            <a:ext cx="8229600" cy="1737360"/>
+            <a:off x="457200" y="3200400"/>
+            <a:ext cx="8229600" cy="1828800"/>
           </a:xfrm>
           <a:prstGeom prst="rect">
             <a:avLst/>
@@ -24486,13 +24486,13 @@
           <a:p>
             <a:pPr marL="342900" indent="-342900">
               <a:spcAft>
-                <a:spcPts val="800"/>
+                <a:spcPts val="600"/>
               </a:spcAft>
               <a:buSzPct val="100000"/>
               <a:buChar char="•"/>
             </a:pPr>
             <a:r>
-              <a:rPr lang="en-US" sz="1350" dirty="0">
+              <a:rPr lang="en-US" sz="1300" dirty="0">
                 <a:solidFill>
                   <a:srgbClr val="2B2B2B"/>
                 </a:solidFill>
@@ -24502,18 +24502,18 @@
               </a:rPr>
               <a:t>Input is an image: one row per data channel (e.g. |S11|, ∠S11, …), one column per frequency point (791).</a:t>
             </a:r>
-            <a:endParaRPr lang="en-US" sz="1350" dirty="0"/>
+            <a:endParaRPr lang="en-US" sz="1300" dirty="0"/>
           </a:p>
           <a:p>
             <a:pPr marL="342900" indent="-342900">
               <a:spcAft>
-                <a:spcPts val="800"/>
+                <a:spcPts val="600"/>
               </a:spcAft>
               <a:buSzPct val="100000"/>
               <a:buChar char="•"/>
             </a:pPr>
             <a:r>
-              <a:rPr lang="en-US" sz="1350" dirty="0">
+              <a:rPr lang="en-US" sz="1300" dirty="0">
                 <a:solidFill>
                   <a:srgbClr val="2B2B2B"/>
                 </a:solidFill>
@@ -24523,18 +24523,18 @@
               </a:rPr>
               <a:t>Two convolution layers (32 filters each) detect local patterns such as resonance shifts and ripples anywhere along the spectrum, sharing weights across frequency.</a:t>
             </a:r>
-            <a:endParaRPr lang="en-US" sz="1350" dirty="0"/>
+            <a:endParaRPr lang="en-US" sz="1300" dirty="0"/>
           </a:p>
           <a:p>
             <a:pPr marL="342900" indent="-342900">
               <a:spcAft>
-                <a:spcPts val="800"/>
+                <a:spcPts val="600"/>
               </a:spcAft>
               <a:buSzPct val="100000"/>
               <a:buChar char="•"/>
             </a:pPr>
             <a:r>
-              <a:rPr lang="en-US" sz="1350" dirty="0">
+              <a:rPr lang="en-US" sz="1300" dirty="0">
                 <a:solidFill>
                   <a:srgbClr val="2B2B2B"/>
                 </a:solidFill>
@@ -24544,18 +24544,18 @@
               </a:rPr>
               <a:t>Batch-normalisation + ReLU after every layer; 30% dropout fights overfitting.</a:t>
             </a:r>
-            <a:endParaRPr lang="en-US" sz="1350" dirty="0"/>
+            <a:endParaRPr lang="en-US" sz="1300" dirty="0"/>
           </a:p>
           <a:p>
             <a:pPr marL="342900" indent="-342900">
               <a:spcAft>
-                <a:spcPts val="800"/>
+                <a:spcPts val="600"/>
               </a:spcAft>
               <a:buSzPct val="100000"/>
               <a:buChar char="•"/>
             </a:pPr>
             <a:r>
-              <a:rPr lang="en-US" sz="1350" dirty="0">
+              <a:rPr lang="en-US" sz="1300" dirty="0">
                 <a:solidFill>
                   <a:srgbClr val="2B2B2B"/>
                 </a:solidFill>
@@ -24565,7 +24565,28 @@
               </a:rPr>
               <a:t>One network, trained 100 epochs with Adam (batch 16) on the GPU; softmax outputs one probability per grid position.</a:t>
             </a:r>
-            <a:endParaRPr lang="en-US" sz="1350" dirty="0"/>
+            <a:endParaRPr lang="en-US" sz="1300" dirty="0"/>
+          </a:p>
+          <a:p>
+            <a:pPr marL="342900" indent="-342900">
+              <a:spcAft>
+                <a:spcPts val="600"/>
+              </a:spcAft>
+              <a:buSzPct val="100000"/>
+              <a:buChar char="•"/>
+            </a:pPr>
+            <a:r>
+              <a:rPr lang="en-US" sz="1300" dirty="0">
+                <a:solidFill>
+                  <a:srgbClr val="2B2B2B"/>
+                </a:solidFill>
+                <a:latin typeface="Calibri" pitchFamily="34" charset="0"/>
+                <a:ea typeface="Calibri" pitchFamily="34" charset="-122"/>
+                <a:cs typeface="Calibri" pitchFamily="34" charset="-120"/>
+              </a:rPr>
+              <a:t>Cost: 5-45 min per LOSO fold on a laptop GPU (input-size dependent); the slowest configs take hours per evaluation.</a:t>
+            </a:r>
+            <a:endParaRPr lang="en-US" sz="1300" dirty="0"/>
           </a:p>
         </p:txBody>
       </p:sp>
@@ -24711,8 +24732,8 @@
         </p:nvSpPr>
         <p:spPr>
           <a:xfrm>
-            <a:off x="457200" y="3246120"/>
-            <a:ext cx="8229600" cy="1737360"/>
+            <a:off x="457200" y="3200400"/>
+            <a:ext cx="8229600" cy="1828800"/>
           </a:xfrm>
           <a:prstGeom prst="rect">
             <a:avLst/>
@@ -24726,13 +24747,13 @@
           <a:p>
             <a:pPr marL="342900" indent="-342900">
               <a:spcAft>
-                <a:spcPts val="800"/>
+                <a:spcPts val="600"/>
               </a:spcAft>
               <a:buSzPct val="100000"/>
               <a:buChar char="•"/>
             </a:pPr>
             <a:r>
-              <a:rPr lang="en-US" sz="1350" dirty="0">
+              <a:rPr lang="en-US" sz="1300" dirty="0">
                 <a:solidFill>
                   <a:srgbClr val="2B2B2B"/>
                 </a:solidFill>
@@ -24742,18 +24763,18 @@
               </a:rPr>
               <a:t>Input is a flat vector: all channels and frequencies concatenated (thousands of features). No spatial structure is assumed.</a:t>
             </a:r>
-            <a:endParaRPr lang="en-US" sz="1350" dirty="0"/>
+            <a:endParaRPr lang="en-US" sz="1300" dirty="0"/>
           </a:p>
           <a:p>
             <a:pPr marL="342900" indent="-342900">
               <a:spcAft>
-                <a:spcPts val="800"/>
+                <a:spcPts val="600"/>
               </a:spcAft>
               <a:buSzPct val="100000"/>
               <a:buChar char="•"/>
             </a:pPr>
             <a:r>
-              <a:rPr lang="en-US" sz="1350" dirty="0">
+              <a:rPr lang="en-US" sz="1300" dirty="0">
                 <a:solidFill>
                   <a:srgbClr val="2B2B2B"/>
                 </a:solidFill>
@@ -24763,18 +24784,18 @@
               </a:rPr>
               <a:t>Two dense layers (256 → 128, ReLU): every feature can interact with every other, but nothing is shared or localized.</a:t>
             </a:r>
-            <a:endParaRPr lang="en-US" sz="1350" dirty="0"/>
+            <a:endParaRPr lang="en-US" sz="1300" dirty="0"/>
           </a:p>
           <a:p>
             <a:pPr marL="342900" indent="-342900">
               <a:spcAft>
-                <a:spcPts val="800"/>
+                <a:spcPts val="600"/>
               </a:spcAft>
               <a:buSzPct val="100000"/>
               <a:buChar char="•"/>
             </a:pPr>
             <a:r>
-              <a:rPr lang="en-US" sz="1350" dirty="0">
+              <a:rPr lang="en-US" sz="1300" dirty="0">
                 <a:solidFill>
                   <a:srgbClr val="2B2B2B"/>
                 </a:solidFill>
@@ -24784,18 +24805,18 @@
               </a:rPr>
               <a:t>Early stopping on a held-out validation split prevents overtraining.</a:t>
             </a:r>
-            <a:endParaRPr lang="en-US" sz="1350" dirty="0"/>
+            <a:endParaRPr lang="en-US" sz="1300" dirty="0"/>
           </a:p>
           <a:p>
             <a:pPr marL="342900" indent="-342900">
               <a:spcAft>
-                <a:spcPts val="800"/>
+                <a:spcPts val="600"/>
               </a:spcAft>
               <a:buSzPct val="100000"/>
               <a:buChar char="•"/>
             </a:pPr>
             <a:r>
-              <a:rPr lang="en-US" sz="1350" dirty="0">
+              <a:rPr lang="en-US" sz="1300" dirty="0">
                 <a:solidFill>
                   <a:srgbClr val="2B2B2B"/>
                 </a:solidFill>
@@ -24805,7 +24826,28 @@
               </a:rPr>
               <a:t>Ensemble: 3 networks with different random seeds are averaged, plus a logistic-regression model; the ensemble vote is the prediction.</a:t>
             </a:r>
-            <a:endParaRPr lang="en-US" sz="1350" dirty="0"/>
+            <a:endParaRPr lang="en-US" sz="1300" dirty="0"/>
+          </a:p>
+          <a:p>
+            <a:pPr marL="342900" indent="-342900">
+              <a:spcAft>
+                <a:spcPts val="600"/>
+              </a:spcAft>
+              <a:buSzPct val="100000"/>
+              <a:buChar char="•"/>
+            </a:pPr>
+            <a:r>
+              <a:rPr lang="en-US" sz="1300" dirty="0">
+                <a:solidFill>
+                  <a:srgbClr val="2B2B2B"/>
+                </a:solidFill>
+                <a:latin typeface="Calibri" pitchFamily="34" charset="0"/>
+                <a:ea typeface="Calibri" pitchFamily="34" charset="-122"/>
+                <a:cs typeface="Calibri" pitchFamily="34" charset="-120"/>
+              </a:rPr>
+              <a:t>Cost: seconds to a few minutes per LOSO fold on a plain CPU; the full study sweep trains ~10x faster than the CNN's.</a:t>
+            </a:r>
+            <a:endParaRPr lang="en-US" sz="1300" dirty="0"/>
           </a:p>
         </p:txBody>
       </p:sp>
@@ -24934,7 +24976,7 @@
           </p:nvPr>
         </p:nvGraphicFramePr>
         <p:xfrm>
-          <a:off x="457200" y="1417320"/>
+          <a:off x="457200" y="1371600"/>
           <a:ext cx="8229600" cy="914400"/>
         </p:xfrm>
         <a:graphic>
@@ -24946,7 +24988,7 @@
                 <a:gridCol w="3063240"/>
                 <a:gridCol w="3063240"/>
               </a:tblGrid>
-              <a:tr h="457200">
+              <a:tr h="402336">
                 <a:tc>
                   <a:txBody>
                     <a:bodyPr/>
@@ -25141,7 +25183,7 @@
                   </a:tcPr>
                 </a:tc>
               </a:tr>
-              <a:tr h="457200">
+              <a:tr h="402336">
                 <a:tc>
                   <a:txBody>
                     <a:bodyPr/>
@@ -25347,7 +25389,7 @@
                   </a:tcPr>
                 </a:tc>
               </a:tr>
-              <a:tr h="457200">
+              <a:tr h="402336">
                 <a:tc>
                   <a:txBody>
                     <a:bodyPr/>
@@ -25553,7 +25595,7 @@
                   </a:tcPr>
                 </a:tc>
               </a:tr>
-              <a:tr h="457200">
+              <a:tr h="402336">
                 <a:tc>
                   <a:txBody>
                     <a:bodyPr/>
@@ -25759,7 +25801,7 @@
                   </a:tcPr>
                 </a:tc>
               </a:tr>
-              <a:tr h="457200">
+              <a:tr h="402336">
                 <a:tc>
                   <a:txBody>
                     <a:bodyPr/>
@@ -25965,7 +26007,7 @@
                   </a:tcPr>
                 </a:tc>
               </a:tr>
-              <a:tr h="457200">
+              <a:tr h="402336">
                 <a:tc>
                   <a:txBody>
                     <a:bodyPr/>
@@ -26171,6 +26213,212 @@
                   </a:tcPr>
                 </a:tc>
               </a:tr>
+              <a:tr h="402336">
+                <a:tc>
+                  <a:txBody>
+                    <a:bodyPr/>
+                    <a:lstStyle/>
+                    <a:p>
+                      <a:pPr algn="l" indent="0" marL="0">
+                        <a:buNone/>
+                      </a:pPr>
+                      <a:r>
+                        <a:rPr lang="en-US" sz="1250" b="1" dirty="0">
+                          <a:solidFill>
+                            <a:srgbClr val="2B2B2B"/>
+                          </a:solidFill>
+                          <a:latin typeface="Calibri" pitchFamily="34" charset="0"/>
+                          <a:ea typeface="Calibri" pitchFamily="34" charset="-122"/>
+                          <a:cs typeface="Calibri" pitchFamily="34" charset="-120"/>
+                        </a:rPr>
+                        <a:t>Training time</a:t>
+                      </a:r>
+                      <a:endParaRPr lang="en-US" sz="1250" dirty="0">
+                        <a:latin typeface="Calibri" charset="0"/>
+                        <a:ea typeface="Calibri" charset="0"/>
+                        <a:cs typeface="Calibri" charset="0"/>
+                      </a:endParaRPr>
+                    </a:p>
+                  </a:txBody>
+                  <a:tcPr marL="91440" marR="91440" marT="45720" marB="45720" anchor="ctr">
+                    <a:lnL w="9525" cap="flat" cmpd="sng" algn="ctr">
+                      <a:solidFill>
+                        <a:srgbClr val="D9D9D9"/>
+                      </a:solidFill>
+                      <a:prstDash val="solid"/>
+                      <a:round/>
+                      <a:headEnd type="none" w="med" len="med"/>
+                      <a:tailEnd type="none" w="med" len="med"/>
+                    </a:lnL>
+                    <a:lnR w="9525" cap="flat" cmpd="sng" algn="ctr">
+                      <a:solidFill>
+                        <a:srgbClr val="D9D9D9"/>
+                      </a:solidFill>
+                      <a:prstDash val="solid"/>
+                      <a:round/>
+                      <a:headEnd type="none" w="med" len="med"/>
+                      <a:tailEnd type="none" w="med" len="med"/>
+                    </a:lnR>
+                    <a:lnT w="9525" cap="flat" cmpd="sng" algn="ctr">
+                      <a:solidFill>
+                        <a:srgbClr val="D9D9D9"/>
+                      </a:solidFill>
+                      <a:prstDash val="solid"/>
+                      <a:round/>
+                      <a:headEnd type="none" w="med" len="med"/>
+                      <a:tailEnd type="none" w="med" len="med"/>
+                    </a:lnT>
+                    <a:lnB w="9525" cap="flat" cmpd="sng" algn="ctr">
+                      <a:solidFill>
+                        <a:srgbClr val="D9D9D9"/>
+                      </a:solidFill>
+                      <a:prstDash val="solid"/>
+                      <a:round/>
+                      <a:headEnd type="none" w="med" len="med"/>
+                      <a:tailEnd type="none" w="med" len="med"/>
+                    </a:lnB>
+                    <a:solidFill>
+                      <a:srgbClr val="FBEDED"/>
+                    </a:solidFill>
+                  </a:tcPr>
+                </a:tc>
+                <a:tc>
+                  <a:txBody>
+                    <a:bodyPr/>
+                    <a:lstStyle/>
+                    <a:p>
+                      <a:pPr algn="l" indent="0" marL="0">
+                        <a:buNone/>
+                      </a:pPr>
+                      <a:r>
+                        <a:rPr lang="en-US" sz="1250" dirty="0">
+                          <a:solidFill>
+                            <a:srgbClr val="2B2B2B"/>
+                          </a:solidFill>
+                          <a:latin typeface="Calibri" pitchFamily="34" charset="0"/>
+                          <a:ea typeface="Calibri" pitchFamily="34" charset="-122"/>
+                          <a:cs typeface="Calibri" pitchFamily="34" charset="-120"/>
+                        </a:rPr>
+                        <a:t>5-45 min per LOSO fold (GPU); ~20 h for the full sweep</a:t>
+                      </a:r>
+                      <a:endParaRPr lang="en-US" sz="1250" dirty="0">
+                        <a:latin typeface="Calibri" charset="0"/>
+                        <a:ea typeface="Calibri" charset="0"/>
+                        <a:cs typeface="Calibri" charset="0"/>
+                      </a:endParaRPr>
+                    </a:p>
+                  </a:txBody>
+                  <a:tcPr marL="91440" marR="91440" marT="45720" marB="45720" anchor="ctr">
+                    <a:lnL w="9525" cap="flat" cmpd="sng" algn="ctr">
+                      <a:solidFill>
+                        <a:srgbClr val="D9D9D9"/>
+                      </a:solidFill>
+                      <a:prstDash val="solid"/>
+                      <a:round/>
+                      <a:headEnd type="none" w="med" len="med"/>
+                      <a:tailEnd type="none" w="med" len="med"/>
+                    </a:lnL>
+                    <a:lnR w="9525" cap="flat" cmpd="sng" algn="ctr">
+                      <a:solidFill>
+                        <a:srgbClr val="D9D9D9"/>
+                      </a:solidFill>
+                      <a:prstDash val="solid"/>
+                      <a:round/>
+                      <a:headEnd type="none" w="med" len="med"/>
+                      <a:tailEnd type="none" w="med" len="med"/>
+                    </a:lnR>
+                    <a:lnT w="9525" cap="flat" cmpd="sng" algn="ctr">
+                      <a:solidFill>
+                        <a:srgbClr val="D9D9D9"/>
+                      </a:solidFill>
+                      <a:prstDash val="solid"/>
+                      <a:round/>
+                      <a:headEnd type="none" w="med" len="med"/>
+                      <a:tailEnd type="none" w="med" len="med"/>
+                    </a:lnT>
+                    <a:lnB w="9525" cap="flat" cmpd="sng" algn="ctr">
+                      <a:solidFill>
+                        <a:srgbClr val="D9D9D9"/>
+                      </a:solidFill>
+                      <a:prstDash val="solid"/>
+                      <a:round/>
+                      <a:headEnd type="none" w="med" len="med"/>
+                      <a:tailEnd type="none" w="med" len="med"/>
+                    </a:lnB>
+                    <a:solidFill>
+                      <a:srgbClr val="FBEDED"/>
+                    </a:solidFill>
+                  </a:tcPr>
+                </a:tc>
+                <a:tc>
+                  <a:txBody>
+                    <a:bodyPr/>
+                    <a:lstStyle/>
+                    <a:p>
+                      <a:pPr algn="l" indent="0" marL="0">
+                        <a:buNone/>
+                      </a:pPr>
+                      <a:r>
+                        <a:rPr lang="en-US" sz="1250" dirty="0">
+                          <a:solidFill>
+                            <a:srgbClr val="2B2B2B"/>
+                          </a:solidFill>
+                          <a:latin typeface="Calibri" pitchFamily="34" charset="0"/>
+                          <a:ea typeface="Calibri" pitchFamily="34" charset="-122"/>
+                          <a:cs typeface="Calibri" pitchFamily="34" charset="-120"/>
+                        </a:rPr>
+                        <a:t>10 s-7 min per fold (CPU); ~3-4 h for the same sweep</a:t>
+                      </a:r>
+                      <a:endParaRPr lang="en-US" sz="1250" dirty="0">
+                        <a:latin typeface="Calibri" charset="0"/>
+                        <a:ea typeface="Calibri" charset="0"/>
+                        <a:cs typeface="Calibri" charset="0"/>
+                      </a:endParaRPr>
+                    </a:p>
+                  </a:txBody>
+                  <a:tcPr marL="91440" marR="91440" marT="45720" marB="45720" anchor="ctr">
+                    <a:lnL w="9525" cap="flat" cmpd="sng" algn="ctr">
+                      <a:solidFill>
+                        <a:srgbClr val="D9D9D9"/>
+                      </a:solidFill>
+                      <a:prstDash val="solid"/>
+                      <a:round/>
+                      <a:headEnd type="none" w="med" len="med"/>
+                      <a:tailEnd type="none" w="med" len="med"/>
+                    </a:lnL>
+                    <a:lnR w="9525" cap="flat" cmpd="sng" algn="ctr">
+                      <a:solidFill>
+                        <a:srgbClr val="D9D9D9"/>
+                      </a:solidFill>
+                      <a:prstDash val="solid"/>
+                      <a:round/>
+                      <a:headEnd type="none" w="med" len="med"/>
+                      <a:tailEnd type="none" w="med" len="med"/>
+                    </a:lnR>
+                    <a:lnT w="9525" cap="flat" cmpd="sng" algn="ctr">
+                      <a:solidFill>
+                        <a:srgbClr val="D9D9D9"/>
+                      </a:solidFill>
+                      <a:prstDash val="solid"/>
+                      <a:round/>
+                      <a:headEnd type="none" w="med" len="med"/>
+                      <a:tailEnd type="none" w="med" len="med"/>
+                    </a:lnT>
+                    <a:lnB w="9525" cap="flat" cmpd="sng" algn="ctr">
+                      <a:solidFill>
+                        <a:srgbClr val="D9D9D9"/>
+                      </a:solidFill>
+                      <a:prstDash val="solid"/>
+                      <a:round/>
+                      <a:headEnd type="none" w="med" len="med"/>
+                      <a:tailEnd type="none" w="med" len="med"/>
+                    </a:lnB>
+                    <a:solidFill>
+                      <a:srgbClr val="FBEDED"/>
+                    </a:solidFill>
+                  </a:tcPr>
+                </a:tc>
+              </a:tr>
             </a:tbl>
           </a:graphicData>
         </a:graphic>
@@ -26183,12 +26431,12 @@
         </p:nvSpPr>
         <p:spPr>
           <a:xfrm>
-            <a:off x="457200" y="4343400"/>
-            <a:ext cx="8229600" cy="566928"/>
+            <a:off x="457200" y="4370832"/>
+            <a:ext cx="8229600" cy="658368"/>
           </a:xfrm>
           <a:prstGeom prst="roundRect">
             <a:avLst>
-              <a:gd name="adj" fmla="val 9677"/>
+              <a:gd name="adj" fmla="val 8333"/>
             </a:avLst>
           </a:prstGeom>
           <a:solidFill>
@@ -26210,8 +26458,8 @@
         </p:nvSpPr>
         <p:spPr>
           <a:xfrm>
-            <a:off x="658368" y="4343400"/>
-            <a:ext cx="7863840" cy="566928"/>
+            <a:off x="658368" y="4370832"/>
+            <a:ext cx="7863840" cy="658368"/>
           </a:xfrm>
           <a:prstGeom prst="rect">
             <a:avLst/>
@@ -26227,7 +26475,7 @@
               <a:buNone/>
             </a:pPr>
             <a:r>
-              <a:rPr lang="en-US" sz="1350" dirty="0">
+              <a:rPr lang="en-US" sz="1250" dirty="0">
                 <a:solidFill>
                   <a:srgbClr val="2B2B2B"/>
                 </a:solidFill>
@@ -26235,9 +26483,9 @@
                 <a:ea typeface="Calibri" pitchFamily="34" charset="-122"/>
                 <a:cs typeface="Calibri" pitchFamily="34" charset="-120"/>
               </a:rPr>
-              <a:t>Same job, opposite philosophies: the CNN assumes frequency-local structure; the MLP assumes nothing. Everything else in this study is held identical.</a:t>
+              <a:t>Same job, opposite philosophies: the CNN assumes frequency-local structure; the MLP assumes nothing. The CNN buys its accuracy with compute: roughly 10x the training time, even with a GPU. Inference is milliseconds for both.</a:t>
             </a:r>
-            <a:endParaRPr lang="en-US" sz="1350" dirty="0"/>
+            <a:endParaRPr lang="en-US" sz="1250" dirty="0"/>
           </a:p>
         </p:txBody>
       </p:sp>

</xml_diff>